<commit_message>
Boubacar seamless carousel: logo in the empty right column on the question slide
Co-Authored-By: Claude Opus 5.5 <noreply@anthropic.com>
Claude-Session: https://claude.ai/code/session_014HGzAbxBh54nuyJHG7tse8
</commit_message>
<xml_diff>
--- a/templates/posts/october/01-10-2026-thu-ig-soil-regenerators-boubacar-panorama-brand-colours.pptx
+++ b/templates/posts/october/01-10-2026-thu-ig-soil-regenerators-boubacar-panorama-brand-colours.pptx
@@ -4294,7 +4294,7 @@
       </p:sp>
       <p:pic>
         <p:nvPicPr>
-          <p:cNvPr id="4" name="Picture 3" descr="1677417520377598295.jpg"/>
+          <p:cNvPr id="4" name="Picture 3" descr="4448636833337350324.jpg"/>
           <p:cNvPicPr>
             <a:picLocks noChangeAspect="1"/>
           </p:cNvPicPr>
@@ -4651,7 +4651,7 @@
       </p:sp>
       <p:pic>
         <p:nvPicPr>
-          <p:cNvPr id="4" name="Picture 3" descr="6349404788244683119.jpg"/>
+          <p:cNvPr id="4" name="Picture 3" descr="485479763096127206.jpg"/>
           <p:cNvPicPr>
             <a:picLocks noChangeAspect="1"/>
           </p:cNvPicPr>
@@ -4725,7 +4725,7 @@
       </p:sp>
       <p:pic>
         <p:nvPicPr>
-          <p:cNvPr id="6" name="Picture 5" descr="493954315249968593.jpg"/>
+          <p:cNvPr id="6" name="Picture 5" descr="6187325532314078297.jpg"/>
           <p:cNvPicPr>
             <a:picLocks noChangeAspect="1"/>
           </p:cNvPicPr>
@@ -4971,7 +4971,7 @@
       </p:sp>
       <p:pic>
         <p:nvPicPr>
-          <p:cNvPr id="4" name="Picture 3" descr="645246947555069473.jpg"/>
+          <p:cNvPr id="4" name="Picture 3" descr="962707502245353702.jpg"/>
           <p:cNvPicPr>
             <a:picLocks noChangeAspect="1"/>
           </p:cNvPicPr>
@@ -5280,7 +5280,7 @@
       </p:sp>
       <p:pic>
         <p:nvPicPr>
-          <p:cNvPr id="4" name="Picture 3" descr="578014039016163329.jpg"/>
+          <p:cNvPr id="4" name="Picture 3" descr="6946211306651335818.jpg"/>
           <p:cNvPicPr>
             <a:picLocks noChangeAspect="1"/>
           </p:cNvPicPr>
@@ -5354,7 +5354,7 @@
       </p:sp>
       <p:pic>
         <p:nvPicPr>
-          <p:cNvPr id="6" name="Picture 5" descr="3580556196138254228.jpg"/>
+          <p:cNvPr id="6" name="Picture 5" descr="8270691107328241953.jpg"/>
           <p:cNvPicPr>
             <a:picLocks noChangeAspect="1"/>
           </p:cNvPicPr>
@@ -5428,7 +5428,7 @@
       </p:sp>
       <p:pic>
         <p:nvPicPr>
-          <p:cNvPr id="8" name="Picture 7" descr="8787833396679771900.jpg"/>
+          <p:cNvPr id="8" name="Picture 7" descr="686785323634843258.jpg"/>
           <p:cNvPicPr>
             <a:picLocks noChangeAspect="1"/>
           </p:cNvPicPr>
@@ -5713,7 +5713,7 @@
       </p:sp>
       <p:pic>
         <p:nvPicPr>
-          <p:cNvPr id="4" name="Picture 3" descr="2018266561391986877.jpg"/>
+          <p:cNvPr id="4" name="Picture 3" descr="4176865102700135565.jpg"/>
           <p:cNvPicPr>
             <a:picLocks noChangeAspect="1"/>
           </p:cNvPicPr>
@@ -5774,9 +5774,33 @@
           </a:p>
         </p:txBody>
       </p:sp>
-      <p:sp>
-        <p:nvSpPr>
-          <p:cNvPr id="6" name="Rectangle 5"/>
+      <p:pic>
+        <p:nvPicPr>
+          <p:cNvPr id="6" name="Picture 5" descr="foundation-logo-color.png"/>
+          <p:cNvPicPr>
+            <a:picLocks noChangeAspect="1"/>
+          </p:cNvPicPr>
+          <p:nvPr/>
+        </p:nvPicPr>
+        <p:blipFill>
+          <a:blip r:embed="rId5"/>
+          <a:stretch>
+            <a:fillRect/>
+          </a:stretch>
+        </p:blipFill>
+        <p:spPr>
+          <a:xfrm>
+            <a:off x="7048500" y="4857750"/>
+            <a:ext cx="2286000" cy="2055246"/>
+          </a:xfrm>
+          <a:prstGeom prst="rect">
+            <a:avLst/>
+          </a:prstGeom>
+        </p:spPr>
+      </p:pic>
+      <p:sp>
+        <p:nvSpPr>
+          <p:cNvPr id="7" name="Rectangle 6"/>
           <p:cNvSpPr/>
           <p:nvPr/>
         </p:nvSpPr>
@@ -5828,7 +5852,7 @@
       </p:sp>
       <p:sp>
         <p:nvSpPr>
-          <p:cNvPr id="7" name="TextBox 6"/>
+          <p:cNvPr id="8" name="TextBox 7"/>
           <p:cNvSpPr txBox="1"/>
           <p:nvPr/>
         </p:nvSpPr>
@@ -5867,7 +5891,7 @@
       </p:sp>
       <p:sp>
         <p:nvSpPr>
-          <p:cNvPr id="8" name="TextBox 7"/>
+          <p:cNvPr id="9" name="TextBox 8"/>
           <p:cNvSpPr txBox="1"/>
           <p:nvPr/>
         </p:nvSpPr>
@@ -5906,7 +5930,7 @@
       </p:sp>
       <p:sp>
         <p:nvSpPr>
-          <p:cNvPr id="9" name="TextBox 8"/>
+          <p:cNvPr id="10" name="TextBox 9"/>
           <p:cNvSpPr txBox="1"/>
           <p:nvPr/>
         </p:nvSpPr>
@@ -6037,7 +6061,7 @@
       </p:sp>
       <p:pic>
         <p:nvPicPr>
-          <p:cNvPr id="4" name="Picture 3" descr="3794820572734780164.jpg"/>
+          <p:cNvPr id="4" name="Picture 3" descr="7712775744967568233.jpg"/>
           <p:cNvPicPr>
             <a:picLocks noChangeAspect="1"/>
           </p:cNvPicPr>
@@ -6111,7 +6135,7 @@
       </p:sp>
       <p:pic>
         <p:nvPicPr>
-          <p:cNvPr id="6" name="Picture 5" descr="3414842926943297308.jpg"/>
+          <p:cNvPr id="6" name="Picture 5" descr="5235210071843645278.jpg"/>
           <p:cNvPicPr>
             <a:picLocks noChangeAspect="1"/>
           </p:cNvPicPr>
@@ -6396,7 +6420,7 @@
       </p:sp>
       <p:pic>
         <p:nvPicPr>
-          <p:cNvPr id="4" name="Picture 3" descr="6630424066519225932.jpg"/>
+          <p:cNvPr id="4" name="Picture 3" descr="661474203686082787.jpg"/>
           <p:cNvPicPr>
             <a:picLocks noChangeAspect="1"/>
           </p:cNvPicPr>
@@ -6470,7 +6494,7 @@
       </p:sp>
       <p:pic>
         <p:nvPicPr>
-          <p:cNvPr id="6" name="Picture 5" descr="2322047041572970051.jpg"/>
+          <p:cNvPr id="6" name="Picture 5" descr="4168729907097581526.jpg"/>
           <p:cNvPicPr>
             <a:picLocks noChangeAspect="1"/>
           </p:cNvPicPr>
@@ -6544,7 +6568,7 @@
       </p:sp>
       <p:pic>
         <p:nvPicPr>
-          <p:cNvPr id="8" name="Picture 7" descr="3228888345073824865.jpg"/>
+          <p:cNvPr id="8" name="Picture 7" descr="2056316689110620988.jpg"/>
           <p:cNvPicPr>
             <a:picLocks noChangeAspect="1"/>
           </p:cNvPicPr>
@@ -6790,7 +6814,7 @@
       </p:sp>
       <p:pic>
         <p:nvPicPr>
-          <p:cNvPr id="4" name="Picture 3" descr="3572518032017588508.jpg"/>
+          <p:cNvPr id="4" name="Picture 3" descr="5944242084205430442.jpg"/>
           <p:cNvPicPr>
             <a:picLocks noChangeAspect="1"/>
           </p:cNvPicPr>
@@ -6864,7 +6888,7 @@
       </p:sp>
       <p:pic>
         <p:nvPicPr>
-          <p:cNvPr id="6" name="Picture 5" descr="1829067125694187265.jpg"/>
+          <p:cNvPr id="6" name="Picture 5" descr="2439043041734877097.jpg"/>
           <p:cNvPicPr>
             <a:picLocks noChangeAspect="1"/>
           </p:cNvPicPr>
@@ -7149,7 +7173,7 @@
       </p:sp>
       <p:pic>
         <p:nvPicPr>
-          <p:cNvPr id="4" name="Picture 3" descr="4137664975280850532.jpg"/>
+          <p:cNvPr id="4" name="Picture 3" descr="4961699617584411749.jpg"/>
           <p:cNvPicPr>
             <a:picLocks noChangeAspect="1"/>
           </p:cNvPicPr>
@@ -7223,7 +7247,7 @@
       </p:sp>
       <p:pic>
         <p:nvPicPr>
-          <p:cNvPr id="6" name="Picture 5" descr="6611745471279322661.jpg"/>
+          <p:cNvPr id="6" name="Picture 5" descr="5644670244562737498.jpg"/>
           <p:cNvPicPr>
             <a:picLocks noChangeAspect="1"/>
           </p:cNvPicPr>
@@ -7297,7 +7321,7 @@
       </p:sp>
       <p:pic>
         <p:nvPicPr>
-          <p:cNvPr id="8" name="Picture 7" descr="4646113829300165292.jpg"/>
+          <p:cNvPr id="8" name="Picture 7" descr="500485145817314040.jpg"/>
           <p:cNvPicPr>
             <a:picLocks noChangeAspect="1"/>
           </p:cNvPicPr>
@@ -7543,7 +7567,7 @@
       </p:sp>
       <p:pic>
         <p:nvPicPr>
-          <p:cNvPr id="4" name="Picture 3" descr="4880221019584416669.jpg"/>
+          <p:cNvPr id="4" name="Picture 3" descr="1440086552430378968.jpg"/>
           <p:cNvPicPr>
             <a:picLocks noChangeAspect="1"/>
           </p:cNvPicPr>
@@ -7617,7 +7641,7 @@
       </p:sp>
       <p:pic>
         <p:nvPicPr>
-          <p:cNvPr id="6" name="Picture 5" descr="3721755188190042841.jpg"/>
+          <p:cNvPr id="6" name="Picture 5" descr="5000789331846203825.jpg"/>
           <p:cNvPicPr>
             <a:picLocks noChangeAspect="1"/>
           </p:cNvPicPr>
@@ -7902,7 +7926,7 @@
       </p:sp>
       <p:pic>
         <p:nvPicPr>
-          <p:cNvPr id="4" name="Picture 3" descr="8985676688164813491.jpg"/>
+          <p:cNvPr id="4" name="Picture 3" descr="678623781883544644.jpg"/>
           <p:cNvPicPr>
             <a:picLocks noChangeAspect="1"/>
           </p:cNvPicPr>
@@ -7976,7 +8000,7 @@
       </p:sp>
       <p:pic>
         <p:nvPicPr>
-          <p:cNvPr id="6" name="Picture 5" descr="1875495466951514703.jpg"/>
+          <p:cNvPr id="6" name="Picture 5" descr="3008340541212875707.jpg"/>
           <p:cNvPicPr>
             <a:picLocks noChangeAspect="1"/>
           </p:cNvPicPr>
@@ -8050,7 +8074,7 @@
       </p:sp>
       <p:pic>
         <p:nvPicPr>
-          <p:cNvPr id="8" name="Picture 7" descr="3498609933558212607.jpg"/>
+          <p:cNvPr id="8" name="Picture 7" descr="7453140700643733761.jpg"/>
           <p:cNvPicPr>
             <a:picLocks noChangeAspect="1"/>
           </p:cNvPicPr>

</xml_diff>

<commit_message>
Boubacar seamless carousel: no hyphae behind the logos, black card text
Co-Authored-By: Claude Opus 5.5 <noreply@anthropic.com>
Claude-Session: https://claude.ai/code/session_014HGzAbxBh54nuyJHG7tse8
</commit_message>
<xml_diff>
--- a/templates/posts/october/01-10-2026-thu-ig-soil-regenerators-boubacar-panorama-brand-colours.pptx
+++ b/templates/posts/october/01-10-2026-thu-ig-soil-regenerators-boubacar-panorama-brand-colours.pptx
@@ -4294,7 +4294,7 @@
       </p:sp>
       <p:pic>
         <p:nvPicPr>
-          <p:cNvPr id="4" name="Picture 3" descr="4448636833337350324.jpg"/>
+          <p:cNvPr id="4" name="Picture 3" descr="5172761286976426623.jpg"/>
           <p:cNvPicPr>
             <a:picLocks noChangeAspect="1"/>
           </p:cNvPicPr>
@@ -4493,7 +4493,7 @@
             <a:r>
               <a:rPr sz="4200" b="1" i="0">
                 <a:solidFill>
-                  <a:srgbClr val="22371F"/>
+                  <a:srgbClr val="111111"/>
                 </a:solidFill>
                 <a:latin typeface="Montserrat"/>
               </a:rPr>
@@ -4532,7 +4532,7 @@
             <a:r>
               <a:rPr sz="3800" b="0" i="0">
                 <a:solidFill>
-                  <a:srgbClr val="22371F"/>
+                  <a:srgbClr val="111111"/>
                 </a:solidFill>
                 <a:latin typeface="Source Sans 3"/>
               </a:rPr>
@@ -4548,7 +4548,7 @@
             <a:r>
               <a:rPr sz="3800" b="0" i="0">
                 <a:solidFill>
-                  <a:srgbClr val="22371F"/>
+                  <a:srgbClr val="111111"/>
                 </a:solidFill>
                 <a:latin typeface="Source Sans 3"/>
               </a:rPr>
@@ -4651,7 +4651,7 @@
       </p:sp>
       <p:pic>
         <p:nvPicPr>
-          <p:cNvPr id="4" name="Picture 3" descr="485479763096127206.jpg"/>
+          <p:cNvPr id="4" name="Picture 3" descr="1315691948327915256.jpg"/>
           <p:cNvPicPr>
             <a:picLocks noChangeAspect="1"/>
           </p:cNvPicPr>
@@ -4725,7 +4725,7 @@
       </p:sp>
       <p:pic>
         <p:nvPicPr>
-          <p:cNvPr id="6" name="Picture 5" descr="6187325532314078297.jpg"/>
+          <p:cNvPr id="6" name="Picture 5" descr="2209728620627789151.jpg"/>
           <p:cNvPicPr>
             <a:picLocks noChangeAspect="1"/>
           </p:cNvPicPr>
@@ -4829,7 +4829,7 @@
             <a:r>
               <a:rPr sz="4000" b="0" i="1">
                 <a:solidFill>
-                  <a:srgbClr val="22371F"/>
+                  <a:srgbClr val="111111"/>
                 </a:solidFill>
                 <a:latin typeface="EB Garamond"/>
               </a:rPr>
@@ -4971,7 +4971,7 @@
       </p:sp>
       <p:pic>
         <p:nvPicPr>
-          <p:cNvPr id="4" name="Picture 3" descr="962707502245353702.jpg"/>
+          <p:cNvPr id="4" name="Picture 3" descr="6844573664583765707.jpg"/>
           <p:cNvPicPr>
             <a:picLocks noChangeAspect="1"/>
           </p:cNvPicPr>
@@ -5138,7 +5138,7 @@
             <a:r>
               <a:rPr sz="4200" b="0" i="1">
                 <a:solidFill>
-                  <a:srgbClr val="3A2524"/>
+                  <a:srgbClr val="111111"/>
                 </a:solidFill>
                 <a:latin typeface="EB Garamond"/>
               </a:rPr>
@@ -5280,7 +5280,7 @@
       </p:sp>
       <p:pic>
         <p:nvPicPr>
-          <p:cNvPr id="4" name="Picture 3" descr="6946211306651335818.jpg"/>
+          <p:cNvPr id="4" name="Picture 3" descr="4588522237147116767.jpg"/>
           <p:cNvPicPr>
             <a:picLocks noChangeAspect="1"/>
           </p:cNvPicPr>
@@ -5354,7 +5354,7 @@
       </p:sp>
       <p:pic>
         <p:nvPicPr>
-          <p:cNvPr id="6" name="Picture 5" descr="8270691107328241953.jpg"/>
+          <p:cNvPr id="6" name="Picture 5" descr="6496888254463412273.jpg"/>
           <p:cNvPicPr>
             <a:picLocks noChangeAspect="1"/>
           </p:cNvPicPr>
@@ -5428,7 +5428,7 @@
       </p:sp>
       <p:pic>
         <p:nvPicPr>
-          <p:cNvPr id="8" name="Picture 7" descr="686785323634843258.jpg"/>
+          <p:cNvPr id="8" name="Picture 7" descr="2653137696406847657.jpg"/>
           <p:cNvPicPr>
             <a:picLocks noChangeAspect="1"/>
           </p:cNvPicPr>
@@ -5532,7 +5532,7 @@
             <a:r>
               <a:rPr sz="3400" b="1" i="0">
                 <a:solidFill>
-                  <a:srgbClr val="3A2524"/>
+                  <a:srgbClr val="111111"/>
                 </a:solidFill>
                 <a:latin typeface="Montserrat"/>
               </a:rPr>
@@ -5571,7 +5571,7 @@
             <a:r>
               <a:rPr sz="3000" b="0" i="0">
                 <a:solidFill>
-                  <a:srgbClr val="3A2524"/>
+                  <a:srgbClr val="111111"/>
                 </a:solidFill>
                 <a:latin typeface="Source Sans 3"/>
               </a:rPr>
@@ -5713,7 +5713,7 @@
       </p:sp>
       <p:pic>
         <p:nvPicPr>
-          <p:cNvPr id="4" name="Picture 3" descr="4176865102700135565.jpg"/>
+          <p:cNvPr id="4" name="Picture 3" descr="3150327113479162468.jpg"/>
           <p:cNvPicPr>
             <a:picLocks noChangeAspect="1"/>
           </p:cNvPicPr>
@@ -5880,7 +5880,7 @@
             <a:r>
               <a:rPr sz="4200" b="1" i="0">
                 <a:solidFill>
-                  <a:srgbClr val="4C3634"/>
+                  <a:srgbClr val="111111"/>
                 </a:solidFill>
                 <a:latin typeface="Montserrat"/>
               </a:rPr>
@@ -5919,7 +5919,7 @@
             <a:r>
               <a:rPr sz="3800" b="0" i="1">
                 <a:solidFill>
-                  <a:srgbClr val="4C3634"/>
+                  <a:srgbClr val="111111"/>
                 </a:solidFill>
                 <a:latin typeface="EB Garamond"/>
               </a:rPr>
@@ -6061,7 +6061,7 @@
       </p:sp>
       <p:pic>
         <p:nvPicPr>
-          <p:cNvPr id="4" name="Picture 3" descr="7712775744967568233.jpg"/>
+          <p:cNvPr id="4" name="Picture 3" descr="7525192260366673905.jpg"/>
           <p:cNvPicPr>
             <a:picLocks noChangeAspect="1"/>
           </p:cNvPicPr>
@@ -6135,7 +6135,7 @@
       </p:sp>
       <p:pic>
         <p:nvPicPr>
-          <p:cNvPr id="6" name="Picture 5" descr="5235210071843645278.jpg"/>
+          <p:cNvPr id="6" name="Picture 5" descr="6715558183352987233.jpg"/>
           <p:cNvPicPr>
             <a:picLocks noChangeAspect="1"/>
           </p:cNvPicPr>
@@ -6239,7 +6239,7 @@
             <a:r>
               <a:rPr sz="3600" b="1" i="0">
                 <a:solidFill>
-                  <a:srgbClr val="22371F"/>
+                  <a:srgbClr val="111111"/>
                 </a:solidFill>
                 <a:latin typeface="Montserrat"/>
               </a:rPr>
@@ -6278,7 +6278,7 @@
             <a:r>
               <a:rPr sz="3200" b="0" i="0">
                 <a:solidFill>
-                  <a:srgbClr val="22371F"/>
+                  <a:srgbClr val="111111"/>
                 </a:solidFill>
                 <a:latin typeface="Source Sans 3"/>
               </a:rPr>
@@ -6420,7 +6420,7 @@
       </p:sp>
       <p:pic>
         <p:nvPicPr>
-          <p:cNvPr id="4" name="Picture 3" descr="661474203686082787.jpg"/>
+          <p:cNvPr id="4" name="Picture 3" descr="3558031886216476183.jpg"/>
           <p:cNvPicPr>
             <a:picLocks noChangeAspect="1"/>
           </p:cNvPicPr>
@@ -6494,7 +6494,7 @@
       </p:sp>
       <p:pic>
         <p:nvPicPr>
-          <p:cNvPr id="6" name="Picture 5" descr="4168729907097581526.jpg"/>
+          <p:cNvPr id="6" name="Picture 5" descr="32437739487782153.jpg"/>
           <p:cNvPicPr>
             <a:picLocks noChangeAspect="1"/>
           </p:cNvPicPr>
@@ -6568,7 +6568,7 @@
       </p:sp>
       <p:pic>
         <p:nvPicPr>
-          <p:cNvPr id="8" name="Picture 7" descr="2056316689110620988.jpg"/>
+          <p:cNvPr id="8" name="Picture 7" descr="6124421296124012345.jpg"/>
           <p:cNvPicPr>
             <a:picLocks noChangeAspect="1"/>
           </p:cNvPicPr>
@@ -6672,7 +6672,7 @@
             <a:r>
               <a:rPr sz="5000" b="0" i="1">
                 <a:solidFill>
-                  <a:srgbClr val="3A2524"/>
+                  <a:srgbClr val="111111"/>
                 </a:solidFill>
                 <a:latin typeface="EB Garamond"/>
               </a:rPr>
@@ -6814,7 +6814,7 @@
       </p:sp>
       <p:pic>
         <p:nvPicPr>
-          <p:cNvPr id="4" name="Picture 3" descr="5944242084205430442.jpg"/>
+          <p:cNvPr id="4" name="Picture 3" descr="711903890584626752.jpg"/>
           <p:cNvPicPr>
             <a:picLocks noChangeAspect="1"/>
           </p:cNvPicPr>
@@ -6888,7 +6888,7 @@
       </p:sp>
       <p:pic>
         <p:nvPicPr>
-          <p:cNvPr id="6" name="Picture 5" descr="2439043041734877097.jpg"/>
+          <p:cNvPr id="6" name="Picture 5" descr="2201243744005039157.jpg"/>
           <p:cNvPicPr>
             <a:picLocks noChangeAspect="1"/>
           </p:cNvPicPr>
@@ -6992,7 +6992,7 @@
             <a:r>
               <a:rPr sz="4600" b="1" i="0">
                 <a:solidFill>
-                  <a:srgbClr val="4C3634"/>
+                  <a:srgbClr val="111111"/>
                 </a:solidFill>
                 <a:latin typeface="Montserrat"/>
               </a:rPr>
@@ -7031,7 +7031,7 @@
             <a:r>
               <a:rPr sz="4200" b="0" i="0">
                 <a:solidFill>
-                  <a:srgbClr val="4C3634"/>
+                  <a:srgbClr val="111111"/>
                 </a:solidFill>
                 <a:latin typeface="Source Sans 3"/>
               </a:rPr>
@@ -7173,7 +7173,7 @@
       </p:sp>
       <p:pic>
         <p:nvPicPr>
-          <p:cNvPr id="4" name="Picture 3" descr="4961699617584411749.jpg"/>
+          <p:cNvPr id="4" name="Picture 3" descr="6374118309932774845.jpg"/>
           <p:cNvPicPr>
             <a:picLocks noChangeAspect="1"/>
           </p:cNvPicPr>
@@ -7247,7 +7247,7 @@
       </p:sp>
       <p:pic>
         <p:nvPicPr>
-          <p:cNvPr id="6" name="Picture 5" descr="5644670244562737498.jpg"/>
+          <p:cNvPr id="6" name="Picture 5" descr="2133406230589006382.jpg"/>
           <p:cNvPicPr>
             <a:picLocks noChangeAspect="1"/>
           </p:cNvPicPr>
@@ -7321,7 +7321,7 @@
       </p:sp>
       <p:pic>
         <p:nvPicPr>
-          <p:cNvPr id="8" name="Picture 7" descr="500485145817314040.jpg"/>
+          <p:cNvPr id="8" name="Picture 7" descr="2902307527454772148.jpg"/>
           <p:cNvPicPr>
             <a:picLocks noChangeAspect="1"/>
           </p:cNvPicPr>
@@ -7425,7 +7425,7 @@
             <a:r>
               <a:rPr sz="4000" b="0" i="1">
                 <a:solidFill>
-                  <a:srgbClr val="22371F"/>
+                  <a:srgbClr val="111111"/>
                 </a:solidFill>
                 <a:latin typeface="EB Garamond"/>
               </a:rPr>
@@ -7567,7 +7567,7 @@
       </p:sp>
       <p:pic>
         <p:nvPicPr>
-          <p:cNvPr id="4" name="Picture 3" descr="1440086552430378968.jpg"/>
+          <p:cNvPr id="4" name="Picture 3" descr="7080675114758510981.jpg"/>
           <p:cNvPicPr>
             <a:picLocks noChangeAspect="1"/>
           </p:cNvPicPr>
@@ -7641,7 +7641,7 @@
       </p:sp>
       <p:pic>
         <p:nvPicPr>
-          <p:cNvPr id="6" name="Picture 5" descr="5000789331846203825.jpg"/>
+          <p:cNvPr id="6" name="Picture 5" descr="3895156118613625090.jpg"/>
           <p:cNvPicPr>
             <a:picLocks noChangeAspect="1"/>
           </p:cNvPicPr>
@@ -7745,7 +7745,7 @@
             <a:r>
               <a:rPr sz="4200" b="1" i="0">
                 <a:solidFill>
-                  <a:srgbClr val="3A2524"/>
+                  <a:srgbClr val="111111"/>
                 </a:solidFill>
                 <a:latin typeface="Montserrat"/>
               </a:rPr>
@@ -7784,7 +7784,7 @@
             <a:r>
               <a:rPr sz="3800" b="0" i="0">
                 <a:solidFill>
-                  <a:srgbClr val="3A2524"/>
+                  <a:srgbClr val="111111"/>
                 </a:solidFill>
                 <a:latin typeface="Source Sans 3"/>
               </a:rPr>
@@ -7926,7 +7926,7 @@
       </p:sp>
       <p:pic>
         <p:nvPicPr>
-          <p:cNvPr id="4" name="Picture 3" descr="678623781883544644.jpg"/>
+          <p:cNvPr id="4" name="Picture 3" descr="361684024496648014.jpg"/>
           <p:cNvPicPr>
             <a:picLocks noChangeAspect="1"/>
           </p:cNvPicPr>
@@ -8000,7 +8000,7 @@
       </p:sp>
       <p:pic>
         <p:nvPicPr>
-          <p:cNvPr id="6" name="Picture 5" descr="3008340541212875707.jpg"/>
+          <p:cNvPr id="6" name="Picture 5" descr="2329244373961234864.jpg"/>
           <p:cNvPicPr>
             <a:picLocks noChangeAspect="1"/>
           </p:cNvPicPr>
@@ -8074,7 +8074,7 @@
       </p:sp>
       <p:pic>
         <p:nvPicPr>
-          <p:cNvPr id="8" name="Picture 7" descr="7453140700643733761.jpg"/>
+          <p:cNvPr id="8" name="Picture 7" descr="1396909515224761516.jpg"/>
           <p:cNvPicPr>
             <a:picLocks noChangeAspect="1"/>
           </p:cNvPicPr>
@@ -8178,7 +8178,7 @@
             <a:r>
               <a:rPr sz="4200" b="0" i="1">
                 <a:solidFill>
-                  <a:srgbClr val="4C3634"/>
+                  <a:srgbClr val="111111"/>
                 </a:solidFill>
                 <a:latin typeface="EB Garamond"/>
               </a:rPr>

</xml_diff>

<commit_message>
Hyphae panorama: route strands around the logos instead of fading them out
Co-Authored-By: Claude Opus 5.5 <noreply@anthropic.com>
Claude-Session: https://claude.ai/code/session_014HGzAbxBh54nuyJHG7tse8
</commit_message>
<xml_diff>
--- a/templates/posts/october/01-10-2026-thu-ig-soil-regenerators-boubacar-panorama-brand-colours.pptx
+++ b/templates/posts/october/01-10-2026-thu-ig-soil-regenerators-boubacar-panorama-brand-colours.pptx
@@ -4294,7 +4294,7 @@
       </p:sp>
       <p:pic>
         <p:nvPicPr>
-          <p:cNvPr id="4" name="Picture 3" descr="5172761286976426623.jpg"/>
+          <p:cNvPr id="4" name="Picture 3" descr="7586973651569272456.jpg"/>
           <p:cNvPicPr>
             <a:picLocks noChangeAspect="1"/>
           </p:cNvPicPr>
@@ -4651,7 +4651,7 @@
       </p:sp>
       <p:pic>
         <p:nvPicPr>
-          <p:cNvPr id="4" name="Picture 3" descr="1315691948327915256.jpg"/>
+          <p:cNvPr id="4" name="Picture 3" descr="2967222750909314938.jpg"/>
           <p:cNvPicPr>
             <a:picLocks noChangeAspect="1"/>
           </p:cNvPicPr>
@@ -4725,7 +4725,7 @@
       </p:sp>
       <p:pic>
         <p:nvPicPr>
-          <p:cNvPr id="6" name="Picture 5" descr="2209728620627789151.jpg"/>
+          <p:cNvPr id="6" name="Picture 5" descr="8595307242588811329.jpg"/>
           <p:cNvPicPr>
             <a:picLocks noChangeAspect="1"/>
           </p:cNvPicPr>
@@ -4971,7 +4971,7 @@
       </p:sp>
       <p:pic>
         <p:nvPicPr>
-          <p:cNvPr id="4" name="Picture 3" descr="6844573664583765707.jpg"/>
+          <p:cNvPr id="4" name="Picture 3" descr="6622342007202215487.jpg"/>
           <p:cNvPicPr>
             <a:picLocks noChangeAspect="1"/>
           </p:cNvPicPr>
@@ -5280,7 +5280,7 @@
       </p:sp>
       <p:pic>
         <p:nvPicPr>
-          <p:cNvPr id="4" name="Picture 3" descr="4588522237147116767.jpg"/>
+          <p:cNvPr id="4" name="Picture 3" descr="4093852015694594513.jpg"/>
           <p:cNvPicPr>
             <a:picLocks noChangeAspect="1"/>
           </p:cNvPicPr>
@@ -5354,7 +5354,7 @@
       </p:sp>
       <p:pic>
         <p:nvPicPr>
-          <p:cNvPr id="6" name="Picture 5" descr="6496888254463412273.jpg"/>
+          <p:cNvPr id="6" name="Picture 5" descr="7136186603301109376.jpg"/>
           <p:cNvPicPr>
             <a:picLocks noChangeAspect="1"/>
           </p:cNvPicPr>
@@ -5428,7 +5428,7 @@
       </p:sp>
       <p:pic>
         <p:nvPicPr>
-          <p:cNvPr id="8" name="Picture 7" descr="2653137696406847657.jpg"/>
+          <p:cNvPr id="8" name="Picture 7" descr="5329495508501813470.jpg"/>
           <p:cNvPicPr>
             <a:picLocks noChangeAspect="1"/>
           </p:cNvPicPr>
@@ -5713,7 +5713,7 @@
       </p:sp>
       <p:pic>
         <p:nvPicPr>
-          <p:cNvPr id="4" name="Picture 3" descr="3150327113479162468.jpg"/>
+          <p:cNvPr id="4" name="Picture 3" descr="5992672327915802292.jpg"/>
           <p:cNvPicPr>
             <a:picLocks noChangeAspect="1"/>
           </p:cNvPicPr>
@@ -6061,7 +6061,7 @@
       </p:sp>
       <p:pic>
         <p:nvPicPr>
-          <p:cNvPr id="4" name="Picture 3" descr="7525192260366673905.jpg"/>
+          <p:cNvPr id="4" name="Picture 3" descr="2915340870348675252.jpg"/>
           <p:cNvPicPr>
             <a:picLocks noChangeAspect="1"/>
           </p:cNvPicPr>
@@ -6135,7 +6135,7 @@
       </p:sp>
       <p:pic>
         <p:nvPicPr>
-          <p:cNvPr id="6" name="Picture 5" descr="6715558183352987233.jpg"/>
+          <p:cNvPr id="6" name="Picture 5" descr="2842404073383489765.jpg"/>
           <p:cNvPicPr>
             <a:picLocks noChangeAspect="1"/>
           </p:cNvPicPr>
@@ -6420,7 +6420,7 @@
       </p:sp>
       <p:pic>
         <p:nvPicPr>
-          <p:cNvPr id="4" name="Picture 3" descr="3558031886216476183.jpg"/>
+          <p:cNvPr id="4" name="Picture 3" descr="1486678678475057762.jpg"/>
           <p:cNvPicPr>
             <a:picLocks noChangeAspect="1"/>
           </p:cNvPicPr>
@@ -6494,7 +6494,7 @@
       </p:sp>
       <p:pic>
         <p:nvPicPr>
-          <p:cNvPr id="6" name="Picture 5" descr="32437739487782153.jpg"/>
+          <p:cNvPr id="6" name="Picture 5" descr="3241736686045474956.jpg"/>
           <p:cNvPicPr>
             <a:picLocks noChangeAspect="1"/>
           </p:cNvPicPr>
@@ -6568,7 +6568,7 @@
       </p:sp>
       <p:pic>
         <p:nvPicPr>
-          <p:cNvPr id="8" name="Picture 7" descr="6124421296124012345.jpg"/>
+          <p:cNvPr id="8" name="Picture 7" descr="4265730561123809455.jpg"/>
           <p:cNvPicPr>
             <a:picLocks noChangeAspect="1"/>
           </p:cNvPicPr>
@@ -6814,7 +6814,7 @@
       </p:sp>
       <p:pic>
         <p:nvPicPr>
-          <p:cNvPr id="4" name="Picture 3" descr="711903890584626752.jpg"/>
+          <p:cNvPr id="4" name="Picture 3" descr="4376444613338011155.jpg"/>
           <p:cNvPicPr>
             <a:picLocks noChangeAspect="1"/>
           </p:cNvPicPr>
@@ -6888,7 +6888,7 @@
       </p:sp>
       <p:pic>
         <p:nvPicPr>
-          <p:cNvPr id="6" name="Picture 5" descr="2201243744005039157.jpg"/>
+          <p:cNvPr id="6" name="Picture 5" descr="7921478301001970266.jpg"/>
           <p:cNvPicPr>
             <a:picLocks noChangeAspect="1"/>
           </p:cNvPicPr>
@@ -7173,7 +7173,7 @@
       </p:sp>
       <p:pic>
         <p:nvPicPr>
-          <p:cNvPr id="4" name="Picture 3" descr="6374118309932774845.jpg"/>
+          <p:cNvPr id="4" name="Picture 3" descr="4360835983323669173.jpg"/>
           <p:cNvPicPr>
             <a:picLocks noChangeAspect="1"/>
           </p:cNvPicPr>
@@ -7247,7 +7247,7 @@
       </p:sp>
       <p:pic>
         <p:nvPicPr>
-          <p:cNvPr id="6" name="Picture 5" descr="2133406230589006382.jpg"/>
+          <p:cNvPr id="6" name="Picture 5" descr="6081542629110829185.jpg"/>
           <p:cNvPicPr>
             <a:picLocks noChangeAspect="1"/>
           </p:cNvPicPr>
@@ -7321,7 +7321,7 @@
       </p:sp>
       <p:pic>
         <p:nvPicPr>
-          <p:cNvPr id="8" name="Picture 7" descr="2902307527454772148.jpg"/>
+          <p:cNvPr id="8" name="Picture 7" descr="8281014646906050719.jpg"/>
           <p:cNvPicPr>
             <a:picLocks noChangeAspect="1"/>
           </p:cNvPicPr>
@@ -7567,7 +7567,7 @@
       </p:sp>
       <p:pic>
         <p:nvPicPr>
-          <p:cNvPr id="4" name="Picture 3" descr="7080675114758510981.jpg"/>
+          <p:cNvPr id="4" name="Picture 3" descr="1854206675707294944.jpg"/>
           <p:cNvPicPr>
             <a:picLocks noChangeAspect="1"/>
           </p:cNvPicPr>
@@ -7641,7 +7641,7 @@
       </p:sp>
       <p:pic>
         <p:nvPicPr>
-          <p:cNvPr id="6" name="Picture 5" descr="3895156118613625090.jpg"/>
+          <p:cNvPr id="6" name="Picture 5" descr="1765789676824166729.jpg"/>
           <p:cNvPicPr>
             <a:picLocks noChangeAspect="1"/>
           </p:cNvPicPr>
@@ -7926,7 +7926,7 @@
       </p:sp>
       <p:pic>
         <p:nvPicPr>
-          <p:cNvPr id="4" name="Picture 3" descr="361684024496648014.jpg"/>
+          <p:cNvPr id="4" name="Picture 3" descr="4115888031380869040.jpg"/>
           <p:cNvPicPr>
             <a:picLocks noChangeAspect="1"/>
           </p:cNvPicPr>
@@ -8000,7 +8000,7 @@
       </p:sp>
       <p:pic>
         <p:nvPicPr>
-          <p:cNvPr id="6" name="Picture 5" descr="2329244373961234864.jpg"/>
+          <p:cNvPr id="6" name="Picture 5" descr="2143601309436151045.jpg"/>
           <p:cNvPicPr>
             <a:picLocks noChangeAspect="1"/>
           </p:cNvPicPr>
@@ -8074,7 +8074,7 @@
       </p:sp>
       <p:pic>
         <p:nvPicPr>
-          <p:cNvPr id="8" name="Picture 7" descr="1396909515224761516.jpg"/>
+          <p:cNvPr id="8" name="Picture 7" descr="2618200583224995908.jpg"/>
           <p:cNvPicPr>
             <a:picLocks noChangeAspect="1"/>
           </p:cNvPicPr>

</xml_diff>

<commit_message>
Hyphae panorama: branches also routed around the Coffee Day text and the quote marks
Co-Authored-By: Claude Opus 5.5 <noreply@anthropic.com>
Claude-Session: https://claude.ai/code/session_014HGzAbxBh54nuyJHG7tse8
</commit_message>
<xml_diff>
--- a/templates/posts/october/01-10-2026-thu-ig-soil-regenerators-boubacar-panorama-brand-colours.pptx
+++ b/templates/posts/october/01-10-2026-thu-ig-soil-regenerators-boubacar-panorama-brand-colours.pptx
@@ -4294,7 +4294,7 @@
       </p:sp>
       <p:pic>
         <p:nvPicPr>
-          <p:cNvPr id="4" name="Picture 3" descr="7586973651569272456.jpg"/>
+          <p:cNvPr id="4" name="Picture 3" descr="4423479001228396653.jpg"/>
           <p:cNvPicPr>
             <a:picLocks noChangeAspect="1"/>
           </p:cNvPicPr>
@@ -4651,7 +4651,7 @@
       </p:sp>
       <p:pic>
         <p:nvPicPr>
-          <p:cNvPr id="4" name="Picture 3" descr="2967222750909314938.jpg"/>
+          <p:cNvPr id="4" name="Picture 3" descr="7067987487611010861.jpg"/>
           <p:cNvPicPr>
             <a:picLocks noChangeAspect="1"/>
           </p:cNvPicPr>
@@ -4725,7 +4725,7 @@
       </p:sp>
       <p:pic>
         <p:nvPicPr>
-          <p:cNvPr id="6" name="Picture 5" descr="8595307242588811329.jpg"/>
+          <p:cNvPr id="6" name="Picture 5" descr="3898970509945644207.jpg"/>
           <p:cNvPicPr>
             <a:picLocks noChangeAspect="1"/>
           </p:cNvPicPr>
@@ -4971,7 +4971,7 @@
       </p:sp>
       <p:pic>
         <p:nvPicPr>
-          <p:cNvPr id="4" name="Picture 3" descr="6622342007202215487.jpg"/>
+          <p:cNvPr id="4" name="Picture 3" descr="882110016375715092.jpg"/>
           <p:cNvPicPr>
             <a:picLocks noChangeAspect="1"/>
           </p:cNvPicPr>
@@ -5280,7 +5280,7 @@
       </p:sp>
       <p:pic>
         <p:nvPicPr>
-          <p:cNvPr id="4" name="Picture 3" descr="4093852015694594513.jpg"/>
+          <p:cNvPr id="4" name="Picture 3" descr="4791050746083285974.jpg"/>
           <p:cNvPicPr>
             <a:picLocks noChangeAspect="1"/>
           </p:cNvPicPr>
@@ -5354,7 +5354,7 @@
       </p:sp>
       <p:pic>
         <p:nvPicPr>
-          <p:cNvPr id="6" name="Picture 5" descr="7136186603301109376.jpg"/>
+          <p:cNvPr id="6" name="Picture 5" descr="6542151772496726870.jpg"/>
           <p:cNvPicPr>
             <a:picLocks noChangeAspect="1"/>
           </p:cNvPicPr>
@@ -5428,7 +5428,7 @@
       </p:sp>
       <p:pic>
         <p:nvPicPr>
-          <p:cNvPr id="8" name="Picture 7" descr="5329495508501813470.jpg"/>
+          <p:cNvPr id="8" name="Picture 7" descr="8232645796700760627.jpg"/>
           <p:cNvPicPr>
             <a:picLocks noChangeAspect="1"/>
           </p:cNvPicPr>
@@ -5713,7 +5713,7 @@
       </p:sp>
       <p:pic>
         <p:nvPicPr>
-          <p:cNvPr id="4" name="Picture 3" descr="5992672327915802292.jpg"/>
+          <p:cNvPr id="4" name="Picture 3" descr="8541839743459773862.jpg"/>
           <p:cNvPicPr>
             <a:picLocks noChangeAspect="1"/>
           </p:cNvPicPr>
@@ -6061,7 +6061,7 @@
       </p:sp>
       <p:pic>
         <p:nvPicPr>
-          <p:cNvPr id="4" name="Picture 3" descr="2915340870348675252.jpg"/>
+          <p:cNvPr id="4" name="Picture 3" descr="8227479659242183148.jpg"/>
           <p:cNvPicPr>
             <a:picLocks noChangeAspect="1"/>
           </p:cNvPicPr>
@@ -6135,7 +6135,7 @@
       </p:sp>
       <p:pic>
         <p:nvPicPr>
-          <p:cNvPr id="6" name="Picture 5" descr="2842404073383489765.jpg"/>
+          <p:cNvPr id="6" name="Picture 5" descr="8350702755059925851.jpg"/>
           <p:cNvPicPr>
             <a:picLocks noChangeAspect="1"/>
           </p:cNvPicPr>
@@ -6420,7 +6420,7 @@
       </p:sp>
       <p:pic>
         <p:nvPicPr>
-          <p:cNvPr id="4" name="Picture 3" descr="1486678678475057762.jpg"/>
+          <p:cNvPr id="4" name="Picture 3" descr="9136303374065665999.jpg"/>
           <p:cNvPicPr>
             <a:picLocks noChangeAspect="1"/>
           </p:cNvPicPr>
@@ -6494,7 +6494,7 @@
       </p:sp>
       <p:pic>
         <p:nvPicPr>
-          <p:cNvPr id="6" name="Picture 5" descr="3241736686045474956.jpg"/>
+          <p:cNvPr id="6" name="Picture 5" descr="2827310103970770101.jpg"/>
           <p:cNvPicPr>
             <a:picLocks noChangeAspect="1"/>
           </p:cNvPicPr>
@@ -6568,7 +6568,7 @@
       </p:sp>
       <p:pic>
         <p:nvPicPr>
-          <p:cNvPr id="8" name="Picture 7" descr="4265730561123809455.jpg"/>
+          <p:cNvPr id="8" name="Picture 7" descr="4854028387659716163.jpg"/>
           <p:cNvPicPr>
             <a:picLocks noChangeAspect="1"/>
           </p:cNvPicPr>
@@ -6814,7 +6814,7 @@
       </p:sp>
       <p:pic>
         <p:nvPicPr>
-          <p:cNvPr id="4" name="Picture 3" descr="4376444613338011155.jpg"/>
+          <p:cNvPr id="4" name="Picture 3" descr="7092235644990556736.jpg"/>
           <p:cNvPicPr>
             <a:picLocks noChangeAspect="1"/>
           </p:cNvPicPr>
@@ -6888,7 +6888,7 @@
       </p:sp>
       <p:pic>
         <p:nvPicPr>
-          <p:cNvPr id="6" name="Picture 5" descr="7921478301001970266.jpg"/>
+          <p:cNvPr id="6" name="Picture 5" descr="5036814897402873872.jpg"/>
           <p:cNvPicPr>
             <a:picLocks noChangeAspect="1"/>
           </p:cNvPicPr>
@@ -7173,7 +7173,7 @@
       </p:sp>
       <p:pic>
         <p:nvPicPr>
-          <p:cNvPr id="4" name="Picture 3" descr="4360835983323669173.jpg"/>
+          <p:cNvPr id="4" name="Picture 3" descr="8320075119266444145.jpg"/>
           <p:cNvPicPr>
             <a:picLocks noChangeAspect="1"/>
           </p:cNvPicPr>
@@ -7247,7 +7247,7 @@
       </p:sp>
       <p:pic>
         <p:nvPicPr>
-          <p:cNvPr id="6" name="Picture 5" descr="6081542629110829185.jpg"/>
+          <p:cNvPr id="6" name="Picture 5" descr="4294429878387710368.jpg"/>
           <p:cNvPicPr>
             <a:picLocks noChangeAspect="1"/>
           </p:cNvPicPr>
@@ -7321,7 +7321,7 @@
       </p:sp>
       <p:pic>
         <p:nvPicPr>
-          <p:cNvPr id="8" name="Picture 7" descr="8281014646906050719.jpg"/>
+          <p:cNvPr id="8" name="Picture 7" descr="5738271474490405867.jpg"/>
           <p:cNvPicPr>
             <a:picLocks noChangeAspect="1"/>
           </p:cNvPicPr>
@@ -7567,7 +7567,7 @@
       </p:sp>
       <p:pic>
         <p:nvPicPr>
-          <p:cNvPr id="4" name="Picture 3" descr="1854206675707294944.jpg"/>
+          <p:cNvPr id="4" name="Picture 3" descr="8836747932713684565.jpg"/>
           <p:cNvPicPr>
             <a:picLocks noChangeAspect="1"/>
           </p:cNvPicPr>
@@ -7641,7 +7641,7 @@
       </p:sp>
       <p:pic>
         <p:nvPicPr>
-          <p:cNvPr id="6" name="Picture 5" descr="1765789676824166729.jpg"/>
+          <p:cNvPr id="6" name="Picture 5" descr="982687847764468486.jpg"/>
           <p:cNvPicPr>
             <a:picLocks noChangeAspect="1"/>
           </p:cNvPicPr>
@@ -7926,7 +7926,7 @@
       </p:sp>
       <p:pic>
         <p:nvPicPr>
-          <p:cNvPr id="4" name="Picture 3" descr="4115888031380869040.jpg"/>
+          <p:cNvPr id="4" name="Picture 3" descr="4816909391562609495.jpg"/>
           <p:cNvPicPr>
             <a:picLocks noChangeAspect="1"/>
           </p:cNvPicPr>
@@ -8000,7 +8000,7 @@
       </p:sp>
       <p:pic>
         <p:nvPicPr>
-          <p:cNvPr id="6" name="Picture 5" descr="2143601309436151045.jpg"/>
+          <p:cNvPr id="6" name="Picture 5" descr="5640977663272033627.jpg"/>
           <p:cNvPicPr>
             <a:picLocks noChangeAspect="1"/>
           </p:cNvPicPr>
@@ -8074,7 +8074,7 @@
       </p:sp>
       <p:pic>
         <p:nvPicPr>
-          <p:cNvPr id="8" name="Picture 7" descr="2618200583224995908.jpg"/>
+          <p:cNvPr id="8" name="Picture 7" descr="4666834616267133623.jpg"/>
           <p:cNvPicPr>
             <a:picLocks noChangeAspect="1"/>
           </p:cNvPicPr>

</xml_diff>

<commit_message>
Hyphae panorama: no branch through the logo and Coffee Day column on slide 1
Co-Authored-By: Claude Opus 5.5 <noreply@anthropic.com>
Claude-Session: https://claude.ai/code/session_014HGzAbxBh54nuyJHG7tse8
</commit_message>
<xml_diff>
--- a/templates/posts/october/01-10-2026-thu-ig-soil-regenerators-boubacar-panorama-brand-colours.pptx
+++ b/templates/posts/october/01-10-2026-thu-ig-soil-regenerators-boubacar-panorama-brand-colours.pptx
@@ -4294,7 +4294,7 @@
       </p:sp>
       <p:pic>
         <p:nvPicPr>
-          <p:cNvPr id="4" name="Picture 3" descr="4423479001228396653.jpg"/>
+          <p:cNvPr id="4" name="Picture 3" descr="2610229458123200193.jpg"/>
           <p:cNvPicPr>
             <a:picLocks noChangeAspect="1"/>
           </p:cNvPicPr>
@@ -4651,7 +4651,7 @@
       </p:sp>
       <p:pic>
         <p:nvPicPr>
-          <p:cNvPr id="4" name="Picture 3" descr="7067987487611010861.jpg"/>
+          <p:cNvPr id="4" name="Picture 3" descr="1307884732000460501.jpg"/>
           <p:cNvPicPr>
             <a:picLocks noChangeAspect="1"/>
           </p:cNvPicPr>
@@ -4725,7 +4725,7 @@
       </p:sp>
       <p:pic>
         <p:nvPicPr>
-          <p:cNvPr id="6" name="Picture 5" descr="3898970509945644207.jpg"/>
+          <p:cNvPr id="6" name="Picture 5" descr="6175448983966607995.jpg"/>
           <p:cNvPicPr>
             <a:picLocks noChangeAspect="1"/>
           </p:cNvPicPr>
@@ -4971,7 +4971,7 @@
       </p:sp>
       <p:pic>
         <p:nvPicPr>
-          <p:cNvPr id="4" name="Picture 3" descr="882110016375715092.jpg"/>
+          <p:cNvPr id="4" name="Picture 3" descr="8495316350608493004.jpg"/>
           <p:cNvPicPr>
             <a:picLocks noChangeAspect="1"/>
           </p:cNvPicPr>
@@ -5280,7 +5280,7 @@
       </p:sp>
       <p:pic>
         <p:nvPicPr>
-          <p:cNvPr id="4" name="Picture 3" descr="4791050746083285974.jpg"/>
+          <p:cNvPr id="4" name="Picture 3" descr="8780300217426103961.jpg"/>
           <p:cNvPicPr>
             <a:picLocks noChangeAspect="1"/>
           </p:cNvPicPr>
@@ -5354,7 +5354,7 @@
       </p:sp>
       <p:pic>
         <p:nvPicPr>
-          <p:cNvPr id="6" name="Picture 5" descr="6542151772496726870.jpg"/>
+          <p:cNvPr id="6" name="Picture 5" descr="3920962346383551570.jpg"/>
           <p:cNvPicPr>
             <a:picLocks noChangeAspect="1"/>
           </p:cNvPicPr>
@@ -5428,7 +5428,7 @@
       </p:sp>
       <p:pic>
         <p:nvPicPr>
-          <p:cNvPr id="8" name="Picture 7" descr="8232645796700760627.jpg"/>
+          <p:cNvPr id="8" name="Picture 7" descr="2018139557991905739.jpg"/>
           <p:cNvPicPr>
             <a:picLocks noChangeAspect="1"/>
           </p:cNvPicPr>
@@ -5713,7 +5713,7 @@
       </p:sp>
       <p:pic>
         <p:nvPicPr>
-          <p:cNvPr id="4" name="Picture 3" descr="8541839743459773862.jpg"/>
+          <p:cNvPr id="4" name="Picture 3" descr="3621744021845059003.jpg"/>
           <p:cNvPicPr>
             <a:picLocks noChangeAspect="1"/>
           </p:cNvPicPr>
@@ -6061,7 +6061,7 @@
       </p:sp>
       <p:pic>
         <p:nvPicPr>
-          <p:cNvPr id="4" name="Picture 3" descr="8227479659242183148.jpg"/>
+          <p:cNvPr id="4" name="Picture 3" descr="1040643180186949223.jpg"/>
           <p:cNvPicPr>
             <a:picLocks noChangeAspect="1"/>
           </p:cNvPicPr>
@@ -6135,7 +6135,7 @@
       </p:sp>
       <p:pic>
         <p:nvPicPr>
-          <p:cNvPr id="6" name="Picture 5" descr="8350702755059925851.jpg"/>
+          <p:cNvPr id="6" name="Picture 5" descr="4688015628410270225.jpg"/>
           <p:cNvPicPr>
             <a:picLocks noChangeAspect="1"/>
           </p:cNvPicPr>
@@ -6420,7 +6420,7 @@
       </p:sp>
       <p:pic>
         <p:nvPicPr>
-          <p:cNvPr id="4" name="Picture 3" descr="9136303374065665999.jpg"/>
+          <p:cNvPr id="4" name="Picture 3" descr="3198567136878245154.jpg"/>
           <p:cNvPicPr>
             <a:picLocks noChangeAspect="1"/>
           </p:cNvPicPr>
@@ -6494,7 +6494,7 @@
       </p:sp>
       <p:pic>
         <p:nvPicPr>
-          <p:cNvPr id="6" name="Picture 5" descr="2827310103970770101.jpg"/>
+          <p:cNvPr id="6" name="Picture 5" descr="4239235484606482144.jpg"/>
           <p:cNvPicPr>
             <a:picLocks noChangeAspect="1"/>
           </p:cNvPicPr>
@@ -6568,7 +6568,7 @@
       </p:sp>
       <p:pic>
         <p:nvPicPr>
-          <p:cNvPr id="8" name="Picture 7" descr="4854028387659716163.jpg"/>
+          <p:cNvPr id="8" name="Picture 7" descr="5696734037378630954.jpg"/>
           <p:cNvPicPr>
             <a:picLocks noChangeAspect="1"/>
           </p:cNvPicPr>
@@ -6814,7 +6814,7 @@
       </p:sp>
       <p:pic>
         <p:nvPicPr>
-          <p:cNvPr id="4" name="Picture 3" descr="7092235644990556736.jpg"/>
+          <p:cNvPr id="4" name="Picture 3" descr="4554721182025387245.jpg"/>
           <p:cNvPicPr>
             <a:picLocks noChangeAspect="1"/>
           </p:cNvPicPr>
@@ -6888,7 +6888,7 @@
       </p:sp>
       <p:pic>
         <p:nvPicPr>
-          <p:cNvPr id="6" name="Picture 5" descr="5036814897402873872.jpg"/>
+          <p:cNvPr id="6" name="Picture 5" descr="2632089306397914028.jpg"/>
           <p:cNvPicPr>
             <a:picLocks noChangeAspect="1"/>
           </p:cNvPicPr>
@@ -7173,7 +7173,7 @@
       </p:sp>
       <p:pic>
         <p:nvPicPr>
-          <p:cNvPr id="4" name="Picture 3" descr="8320075119266444145.jpg"/>
+          <p:cNvPr id="4" name="Picture 3" descr="545937512602049495.jpg"/>
           <p:cNvPicPr>
             <a:picLocks noChangeAspect="1"/>
           </p:cNvPicPr>
@@ -7247,7 +7247,7 @@
       </p:sp>
       <p:pic>
         <p:nvPicPr>
-          <p:cNvPr id="6" name="Picture 5" descr="4294429878387710368.jpg"/>
+          <p:cNvPr id="6" name="Picture 5" descr="2937009627126702171.jpg"/>
           <p:cNvPicPr>
             <a:picLocks noChangeAspect="1"/>
           </p:cNvPicPr>
@@ -7321,7 +7321,7 @@
       </p:sp>
       <p:pic>
         <p:nvPicPr>
-          <p:cNvPr id="8" name="Picture 7" descr="5738271474490405867.jpg"/>
+          <p:cNvPr id="8" name="Picture 7" descr="9096311990816514092.jpg"/>
           <p:cNvPicPr>
             <a:picLocks noChangeAspect="1"/>
           </p:cNvPicPr>
@@ -7567,7 +7567,7 @@
       </p:sp>
       <p:pic>
         <p:nvPicPr>
-          <p:cNvPr id="4" name="Picture 3" descr="8836747932713684565.jpg"/>
+          <p:cNvPr id="4" name="Picture 3" descr="6676655824062511469.jpg"/>
           <p:cNvPicPr>
             <a:picLocks noChangeAspect="1"/>
           </p:cNvPicPr>
@@ -7641,7 +7641,7 @@
       </p:sp>
       <p:pic>
         <p:nvPicPr>
-          <p:cNvPr id="6" name="Picture 5" descr="982687847764468486.jpg"/>
+          <p:cNvPr id="6" name="Picture 5" descr="8814402525436297749.jpg"/>
           <p:cNvPicPr>
             <a:picLocks noChangeAspect="1"/>
           </p:cNvPicPr>
@@ -7926,7 +7926,7 @@
       </p:sp>
       <p:pic>
         <p:nvPicPr>
-          <p:cNvPr id="4" name="Picture 3" descr="4816909391562609495.jpg"/>
+          <p:cNvPr id="4" name="Picture 3" descr="8172383097861750681.jpg"/>
           <p:cNvPicPr>
             <a:picLocks noChangeAspect="1"/>
           </p:cNvPicPr>
@@ -8000,7 +8000,7 @@
       </p:sp>
       <p:pic>
         <p:nvPicPr>
-          <p:cNvPr id="6" name="Picture 5" descr="5640977663272033627.jpg"/>
+          <p:cNvPr id="6" name="Picture 5" descr="2319349114255376742.jpg"/>
           <p:cNvPicPr>
             <a:picLocks noChangeAspect="1"/>
           </p:cNvPicPr>
@@ -8074,7 +8074,7 @@
       </p:sp>
       <p:pic>
         <p:nvPicPr>
-          <p:cNvPr id="8" name="Picture 7" descr="4666834616267133623.jpg"/>
+          <p:cNvPr id="8" name="Picture 7" descr="8726738700536645505.jpg"/>
           <p:cNvPicPr>
             <a:picLocks noChangeAspect="1"/>
           </p:cNvPicPr>

</xml_diff>